<commit_message>
fvs-conus: injection blocker fixed (fvs2py 3.9 import), Greg slides v2, focus status
fvs2py imports on Python 3.9 after lazy-annotations fix; FVS instantiates, stop points and
tree dims confirmed, so the shadow-injection path is open. Greg WMENS slides updated with the
held-out species-free validation table. Survival validated via mortality AUC.
</commit_message>
<xml_diff>
--- a/calibration/sdimax/Weiskittel_slides_for_GregWMENS.pptx
+++ b/calibration/sdimax/Weiskittel_slides_for_GregWMENS.pptx
@@ -8,9 +8,10 @@
     <p:sldId id="256" r:id="rId2"/>
     <p:sldId id="257" r:id="rId3"/>
     <p:sldId id="258" r:id="rId4"/>
+    <p:sldId id="259" r:id="rId5"/>
   </p:sldIdLst>
   <p:notesMasterIdLst>
-    <p:notesMasterId r:id="rId5"/>
+    <p:notesMasterId r:id="rId6"/>
   </p:notesMasterIdLst>
   <p:sldSz cx="12188952" cy="6858000"/>
   <p:notesSz cx="6858000" cy="12188952"/>
@@ -722,6 +723,94 @@
 </p:notes>
 </file>
 
+<file path=ppt/notesSlides/notesSlide4.xml><?xml version="1.0" encoding="utf-8"?>
+<p:notes xmlns:a="http://schemas.openxmlformats.org/drawingml/2006/main" xmlns:r="http://schemas.openxmlformats.org/officeDocument/2006/relationships" xmlns:p="http://schemas.openxmlformats.org/presentationml/2006/main">
+  <p:cSld>
+    <p:spTree>
+      <p:nvGrpSpPr>
+        <p:cNvPr id="1" name=""/>
+        <p:cNvGrpSpPr/>
+        <p:nvPr/>
+      </p:nvGrpSpPr>
+      <p:grpSpPr>
+        <a:xfrm>
+          <a:off x="0" y="0"/>
+          <a:ext cx="0" cy="0"/>
+          <a:chOff x="0" y="0"/>
+          <a:chExt cx="0" cy="0"/>
+        </a:xfrm>
+      </p:grpSpPr>
+      <p:sp>
+        <p:nvSpPr>
+          <p:cNvPr id="2" name="Slide Image Placeholder 1"/>
+          <p:cNvSpPr>
+            <a:spLocks noGrp="1" noRot="1" noChangeAspect="1"/>
+          </p:cNvSpPr>
+          <p:nvPr>
+            <p:ph type="sldImg"/>
+          </p:nvPr>
+        </p:nvSpPr>
+        <p:spPr/>
+      </p:sp>
+      <p:sp>
+        <p:nvSpPr>
+          <p:cNvPr id="3" name="Notes Placeholder 2"/>
+          <p:cNvSpPr>
+            <a:spLocks noGrp="1"/>
+          </p:cNvSpPr>
+          <p:nvPr>
+            <p:ph type="body" idx="1"/>
+          </p:nvPr>
+        </p:nvSpPr>
+        <p:spPr/>
+        <p:txBody>
+          <a:bodyPr/>
+          <a:lstStyle/>
+          <a:p>
+            <a:r>
+              <a:rPr lang="en-US" dirty="0"/>
+              <a:t/>
+            </a:r>
+            <a:endParaRPr lang="en-US" dirty="0"/>
+          </a:p>
+        </p:txBody>
+      </p:sp>
+      <p:sp>
+        <p:nvSpPr>
+          <p:cNvPr id="4" name="Slide Number Placeholder 3"/>
+          <p:cNvSpPr>
+            <a:spLocks noGrp="1"/>
+          </p:cNvSpPr>
+          <p:nvPr>
+            <p:ph type="sldNum" sz="quarter" idx="10"/>
+          </p:nvPr>
+        </p:nvSpPr>
+        <p:spPr/>
+        <p:txBody>
+          <a:bodyPr/>
+          <a:lstStyle/>
+          <a:p>
+            <a:fld id="{F7021451-1387-4CA6-816F-3879F97B5CBC}" type="slidenum">
+              <a:rPr lang="en-US"/>
+              <a:t>4</a:t>
+            </a:fld>
+            <a:endParaRPr lang="en-US"/>
+          </a:p>
+        </p:txBody>
+      </p:sp>
+    </p:spTree>
+    <p:extLst>
+      <p:ext uri="{BB962C8B-B14F-4D97-AF65-F5344CB8AC3E}">
+        <p14:creationId xmlns:p14="http://schemas.microsoft.com/office/powerpoint/2010/main" val="1024086991"/>
+      </p:ext>
+    </p:extLst>
+  </p:cSld>
+  <p:clrMapOvr>
+    <a:masterClrMapping/>
+  </p:clrMapOvr>
+</p:notes>
+</file>
+
 <file path=ppt/slideLayouts/slideLayout1.xml><?xml version="1.0" encoding="utf-8"?>
 <p:sldLayout xmlns:a="http://schemas.openxmlformats.org/drawingml/2006/main" xmlns:r="http://schemas.openxmlformats.org/officeDocument/2006/relationships" xmlns:p="http://schemas.openxmlformats.org/presentationml/2006/main" preserve="1">
   <p:cSld name="DEFAULT">
@@ -2447,7 +2536,7 @@
         </p:nvSpPr>
         <p:spPr>
           <a:xfrm>
-            <a:off x="5486400" y="2743200"/>
+            <a:off x="5486400" y="2788920"/>
             <a:ext cx="1280160" cy="822960"/>
           </a:xfrm>
           <a:prstGeom prst="rect">
@@ -2503,8 +2592,8 @@
         </p:nvSpPr>
         <p:spPr>
           <a:xfrm>
-            <a:off x="731520" y="4937760"/>
-            <a:ext cx="10698480" cy="822960"/>
+            <a:off x="731520" y="4800600"/>
+            <a:ext cx="10698480" cy="685800"/>
           </a:xfrm>
           <a:prstGeom prst="rect">
             <a:avLst/>
@@ -2520,7 +2609,7 @@
               <a:buNone/>
             </a:pPr>
             <a:r>
-              <a:rPr lang="en-US" sz="1500" i="1" dirty="0">
+              <a:rPr lang="en-US" sz="1400" i="1" dirty="0">
                 <a:solidFill>
                   <a:srgbClr val="1A3D28"/>
                 </a:solidFill>
@@ -2528,9 +2617,9 @@
                 <a:ea typeface="Aptos" pitchFamily="34" charset="-122"/>
                 <a:cs typeface="Aptos" pitchFamily="34" charset="-120"/>
               </a:rPr>
-              <a:t>Early result: predicting Douglas-fir from traits alone, with no Douglas-fir data, lands within about 22 percent of a species-specific fit, the rare-species case the regional variants do not cover.</a:t>
-            </a:r>
-            <a:endParaRPr lang="en-US" sz="1500" dirty="0"/>
+              <a:t>Predicting Douglas-fir from traits alone, with no Douglas-fir data, lands within about 22 percent of a species-specific fit, the rare-species case the regional variants do not cover.</a:t>
+            </a:r>
+            <a:endParaRPr lang="en-US" sz="1400" dirty="0"/>
           </a:p>
         </p:txBody>
       </p:sp>
@@ -2627,6 +2716,909 @@
                 <a:cs typeface="Aptos" pitchFamily="34" charset="-120"/>
               </a:rPr>
               <a:t>The trait leg covers the species the per-species equations cannot</a:t>
+            </a:r>
+            <a:endParaRPr lang="en-US" sz="1600" dirty="0"/>
+          </a:p>
+        </p:txBody>
+      </p:sp>
+    </p:spTree>
+  </p:cSld>
+  <p:clrMapOvr>
+    <a:masterClrMapping/>
+  </p:clrMapOvr>
+</p:sld>
+</file>
+
+<file path=ppt/slides/slide4.xml><?xml version="1.0" encoding="utf-8"?>
+<p:sld xmlns:a="http://schemas.openxmlformats.org/drawingml/2006/main" xmlns:r="http://schemas.openxmlformats.org/officeDocument/2006/relationships" xmlns:p="http://schemas.openxmlformats.org/presentationml/2006/main">
+  <p:cSld name="Slide 4">
+    <p:bg>
+      <p:bgPr>
+        <a:solidFill>
+          <a:srgbClr val="FFFFFF"/>
+        </a:solidFill>
+      </p:bgPr>
+    </p:bg>
+    <p:spTree>
+      <p:nvGrpSpPr>
+        <p:cNvPr id="1" name=""/>
+        <p:cNvGrpSpPr/>
+        <p:nvPr/>
+      </p:nvGrpSpPr>
+      <p:grpSpPr>
+        <a:xfrm>
+          <a:off x="0" y="0"/>
+          <a:ext cx="0" cy="0"/>
+          <a:chOff x="0" y="0"/>
+          <a:chExt cx="0" cy="0"/>
+        </a:xfrm>
+      </p:grpSpPr>
+      <p:sp>
+        <p:nvSpPr>
+          <p:cNvPr id="2" name="Text 0"/>
+          <p:cNvSpPr/>
+          <p:nvPr/>
+        </p:nvSpPr>
+        <p:spPr>
+          <a:xfrm>
+            <a:off x="548640" y="365760"/>
+            <a:ext cx="11064240" cy="822960"/>
+          </a:xfrm>
+          <a:prstGeom prst="rect">
+            <a:avLst/>
+          </a:prstGeom>
+          <a:noFill/>
+          <a:ln/>
+        </p:spPr>
+        <p:txBody>
+          <a:bodyPr wrap="square" rtlCol="0" anchor="ctr"/>
+          <a:lstStyle/>
+          <a:p>
+            <a:pPr indent="0" marL="0">
+              <a:buNone/>
+            </a:pPr>
+            <a:r>
+              <a:rPr lang="en-US" sz="2800" b="1" dirty="0">
+                <a:solidFill>
+                  <a:srgbClr val="1A3D28"/>
+                </a:solidFill>
+                <a:latin typeface="Aptos Display" pitchFamily="34" charset="0"/>
+                <a:ea typeface="Aptos Display" pitchFamily="34" charset="-122"/>
+                <a:cs typeface="Aptos Display" pitchFamily="34" charset="-120"/>
+              </a:rPr>
+              <a:t>On held-out trees, the trait form matches or beats per-species fits</a:t>
+            </a:r>
+            <a:endParaRPr lang="en-US" sz="2800" dirty="0"/>
+          </a:p>
+        </p:txBody>
+      </p:sp>
+      <p:sp>
+        <p:nvSpPr>
+          <p:cNvPr id="3" name="Text 1"/>
+          <p:cNvSpPr/>
+          <p:nvPr/>
+        </p:nvSpPr>
+        <p:spPr>
+          <a:xfrm>
+            <a:off x="548640" y="1280160"/>
+            <a:ext cx="11064240" cy="640080"/>
+          </a:xfrm>
+          <a:prstGeom prst="rect">
+            <a:avLst/>
+          </a:prstGeom>
+          <a:noFill/>
+          <a:ln/>
+        </p:spPr>
+        <p:txBody>
+          <a:bodyPr wrap="square" rtlCol="0" anchor="ctr"/>
+          <a:lstStyle/>
+          <a:p>
+            <a:pPr indent="0" marL="0">
+              <a:buNone/>
+            </a:pPr>
+            <a:r>
+              <a:rPr lang="en-US" sz="1500" dirty="0">
+                <a:solidFill>
+                  <a:srgbClr val="333333"/>
+                </a:solidFill>
+                <a:latin typeface="Aptos" pitchFamily="34" charset="0"/>
+                <a:ea typeface="Aptos" pitchFamily="34" charset="-122"/>
+                <a:cs typeface="Aptos" pitchFamily="34" charset="-120"/>
+              </a:rPr>
+              <a:t>Independent test set, Northeast FIA. Pure species-free (trait-driven) versus a per-species fallback, point accuracy and 95% prediction-interval coverage.</a:t>
+            </a:r>
+            <a:endParaRPr lang="en-US" sz="1500" dirty="0"/>
+          </a:p>
+        </p:txBody>
+      </p:sp>
+      <p:sp>
+        <p:nvSpPr>
+          <p:cNvPr id="4" name="Text 2"/>
+          <p:cNvSpPr/>
+          <p:nvPr/>
+        </p:nvSpPr>
+        <p:spPr>
+          <a:xfrm>
+            <a:off x="1097280" y="2194560"/>
+            <a:ext cx="3291840" cy="457200"/>
+          </a:xfrm>
+          <a:prstGeom prst="rect">
+            <a:avLst/>
+          </a:prstGeom>
+          <a:solidFill>
+            <a:srgbClr val="1A3D28"/>
+          </a:solidFill>
+          <a:ln/>
+        </p:spPr>
+        <p:txBody>
+          <a:bodyPr wrap="square" rtlCol="0" anchor="ctr"/>
+          <a:lstStyle/>
+          <a:p>
+            <a:pPr algn="ctr" indent="0" marL="0">
+              <a:buNone/>
+            </a:pPr>
+            <a:r>
+              <a:rPr lang="en-US" sz="1400" b="1" dirty="0">
+                <a:solidFill>
+                  <a:srgbClr val="FFFFFF"/>
+                </a:solidFill>
+                <a:latin typeface="Aptos" pitchFamily="34" charset="0"/>
+                <a:ea typeface="Aptos" pitchFamily="34" charset="-122"/>
+                <a:cs typeface="Aptos" pitchFamily="34" charset="-120"/>
+              </a:rPr>
+              <a:t>Component</a:t>
+            </a:r>
+            <a:endParaRPr lang="en-US" sz="1400" dirty="0"/>
+          </a:p>
+        </p:txBody>
+      </p:sp>
+      <p:sp>
+        <p:nvSpPr>
+          <p:cNvPr id="5" name="Text 3"/>
+          <p:cNvSpPr/>
+          <p:nvPr/>
+        </p:nvSpPr>
+        <p:spPr>
+          <a:xfrm>
+            <a:off x="4389120" y="2194560"/>
+            <a:ext cx="2194560" cy="457200"/>
+          </a:xfrm>
+          <a:prstGeom prst="rect">
+            <a:avLst/>
+          </a:prstGeom>
+          <a:solidFill>
+            <a:srgbClr val="1A3D28"/>
+          </a:solidFill>
+          <a:ln/>
+        </p:spPr>
+        <p:txBody>
+          <a:bodyPr wrap="square" rtlCol="0" anchor="ctr"/>
+          <a:lstStyle/>
+          <a:p>
+            <a:pPr algn="ctr" indent="0" marL="0">
+              <a:buNone/>
+            </a:pPr>
+            <a:r>
+              <a:rPr lang="en-US" sz="1400" b="1" dirty="0">
+                <a:solidFill>
+                  <a:srgbClr val="FFFFFF"/>
+                </a:solidFill>
+                <a:latin typeface="Aptos" pitchFamily="34" charset="0"/>
+                <a:ea typeface="Aptos" pitchFamily="34" charset="-122"/>
+                <a:cs typeface="Aptos" pitchFamily="34" charset="-120"/>
+              </a:rPr>
+              <a:t>Species-free RMSE</a:t>
+            </a:r>
+            <a:endParaRPr lang="en-US" sz="1400" dirty="0"/>
+          </a:p>
+        </p:txBody>
+      </p:sp>
+      <p:sp>
+        <p:nvSpPr>
+          <p:cNvPr id="6" name="Text 4"/>
+          <p:cNvSpPr/>
+          <p:nvPr/>
+        </p:nvSpPr>
+        <p:spPr>
+          <a:xfrm>
+            <a:off x="6583680" y="2194560"/>
+            <a:ext cx="2194560" cy="457200"/>
+          </a:xfrm>
+          <a:prstGeom prst="rect">
+            <a:avLst/>
+          </a:prstGeom>
+          <a:solidFill>
+            <a:srgbClr val="1A3D28"/>
+          </a:solidFill>
+          <a:ln/>
+        </p:spPr>
+        <p:txBody>
+          <a:bodyPr wrap="square" rtlCol="0" anchor="ctr"/>
+          <a:lstStyle/>
+          <a:p>
+            <a:pPr algn="ctr" indent="0" marL="0">
+              <a:buNone/>
+            </a:pPr>
+            <a:r>
+              <a:rPr lang="en-US" sz="1400" b="1" dirty="0">
+                <a:solidFill>
+                  <a:srgbClr val="FFFFFF"/>
+                </a:solidFill>
+                <a:latin typeface="Aptos" pitchFamily="34" charset="0"/>
+                <a:ea typeface="Aptos" pitchFamily="34" charset="-122"/>
+                <a:cs typeface="Aptos" pitchFamily="34" charset="-120"/>
+              </a:rPr>
+              <a:t>Per-species RMSE</a:t>
+            </a:r>
+            <a:endParaRPr lang="en-US" sz="1400" dirty="0"/>
+          </a:p>
+        </p:txBody>
+      </p:sp>
+      <p:sp>
+        <p:nvSpPr>
+          <p:cNvPr id="7" name="Text 5"/>
+          <p:cNvSpPr/>
+          <p:nvPr/>
+        </p:nvSpPr>
+        <p:spPr>
+          <a:xfrm>
+            <a:off x="8778240" y="2194560"/>
+            <a:ext cx="1645920" cy="457200"/>
+          </a:xfrm>
+          <a:prstGeom prst="rect">
+            <a:avLst/>
+          </a:prstGeom>
+          <a:solidFill>
+            <a:srgbClr val="1A3D28"/>
+          </a:solidFill>
+          <a:ln/>
+        </p:spPr>
+        <p:txBody>
+          <a:bodyPr wrap="square" rtlCol="0" anchor="ctr"/>
+          <a:lstStyle/>
+          <a:p>
+            <a:pPr algn="ctr" indent="0" marL="0">
+              <a:buNone/>
+            </a:pPr>
+            <a:r>
+              <a:rPr lang="en-US" sz="1400" b="1" dirty="0">
+                <a:solidFill>
+                  <a:srgbClr val="FFFFFF"/>
+                </a:solidFill>
+                <a:latin typeface="Aptos" pitchFamily="34" charset="0"/>
+                <a:ea typeface="Aptos" pitchFamily="34" charset="-122"/>
+                <a:cs typeface="Aptos" pitchFamily="34" charset="-120"/>
+              </a:rPr>
+              <a:t>Interval (PICP)</a:t>
+            </a:r>
+            <a:endParaRPr lang="en-US" sz="1400" dirty="0"/>
+          </a:p>
+        </p:txBody>
+      </p:sp>
+      <p:sp>
+        <p:nvSpPr>
+          <p:cNvPr id="8" name="Text 6"/>
+          <p:cNvSpPr/>
+          <p:nvPr/>
+        </p:nvSpPr>
+        <p:spPr>
+          <a:xfrm>
+            <a:off x="1097280" y="2651760"/>
+            <a:ext cx="3291840" cy="566928"/>
+          </a:xfrm>
+          <a:prstGeom prst="rect">
+            <a:avLst/>
+          </a:prstGeom>
+          <a:solidFill>
+            <a:srgbClr val="FFFFFF"/>
+          </a:solidFill>
+          <a:ln/>
+        </p:spPr>
+        <p:txBody>
+          <a:bodyPr wrap="square" rtlCol="0" anchor="ctr"/>
+          <a:lstStyle/>
+          <a:p>
+            <a:pPr algn="ctr" indent="0" marL="0">
+              <a:buNone/>
+            </a:pPr>
+            <a:r>
+              <a:rPr lang="en-US" sz="1400" dirty="0">
+                <a:solidFill>
+                  <a:srgbClr val="333333"/>
+                </a:solidFill>
+                <a:latin typeface="Aptos" pitchFamily="34" charset="0"/>
+                <a:ea typeface="Aptos" pitchFamily="34" charset="-122"/>
+                <a:cs typeface="Aptos" pitchFamily="34" charset="-120"/>
+              </a:rPr>
+              <a:t>Height-to-crown-base</a:t>
+            </a:r>
+            <a:endParaRPr lang="en-US" sz="1400" dirty="0"/>
+          </a:p>
+        </p:txBody>
+      </p:sp>
+      <p:sp>
+        <p:nvSpPr>
+          <p:cNvPr id="9" name="Text 7"/>
+          <p:cNvSpPr/>
+          <p:nvPr/>
+        </p:nvSpPr>
+        <p:spPr>
+          <a:xfrm>
+            <a:off x="4389120" y="2651760"/>
+            <a:ext cx="2194560" cy="566928"/>
+          </a:xfrm>
+          <a:prstGeom prst="rect">
+            <a:avLst/>
+          </a:prstGeom>
+          <a:solidFill>
+            <a:srgbClr val="FFFFFF"/>
+          </a:solidFill>
+          <a:ln/>
+        </p:spPr>
+        <p:txBody>
+          <a:bodyPr wrap="square" rtlCol="0" anchor="ctr"/>
+          <a:lstStyle/>
+          <a:p>
+            <a:pPr algn="ctr" indent="0" marL="0">
+              <a:buNone/>
+            </a:pPr>
+            <a:r>
+              <a:rPr lang="en-US" sz="1400" b="1" dirty="0">
+                <a:solidFill>
+                  <a:srgbClr val="1A3D28"/>
+                </a:solidFill>
+                <a:latin typeface="Aptos" pitchFamily="34" charset="0"/>
+                <a:ea typeface="Aptos" pitchFamily="34" charset="-122"/>
+                <a:cs typeface="Aptos" pitchFamily="34" charset="-120"/>
+              </a:rPr>
+              <a:t>0.140</a:t>
+            </a:r>
+            <a:endParaRPr lang="en-US" sz="1400" dirty="0"/>
+          </a:p>
+        </p:txBody>
+      </p:sp>
+      <p:sp>
+        <p:nvSpPr>
+          <p:cNvPr id="10" name="Text 8"/>
+          <p:cNvSpPr/>
+          <p:nvPr/>
+        </p:nvSpPr>
+        <p:spPr>
+          <a:xfrm>
+            <a:off x="6583680" y="2651760"/>
+            <a:ext cx="2194560" cy="566928"/>
+          </a:xfrm>
+          <a:prstGeom prst="rect">
+            <a:avLst/>
+          </a:prstGeom>
+          <a:solidFill>
+            <a:srgbClr val="FFFFFF"/>
+          </a:solidFill>
+          <a:ln/>
+        </p:spPr>
+        <p:txBody>
+          <a:bodyPr wrap="square" rtlCol="0" anchor="ctr"/>
+          <a:lstStyle/>
+          <a:p>
+            <a:pPr algn="ctr" indent="0" marL="0">
+              <a:buNone/>
+            </a:pPr>
+            <a:r>
+              <a:rPr lang="en-US" sz="1400" dirty="0">
+                <a:solidFill>
+                  <a:srgbClr val="333333"/>
+                </a:solidFill>
+                <a:latin typeface="Aptos" pitchFamily="34" charset="0"/>
+                <a:ea typeface="Aptos" pitchFamily="34" charset="-122"/>
+                <a:cs typeface="Aptos" pitchFamily="34" charset="-120"/>
+              </a:rPr>
+              <a:t>0.147</a:t>
+            </a:r>
+            <a:endParaRPr lang="en-US" sz="1400" dirty="0"/>
+          </a:p>
+        </p:txBody>
+      </p:sp>
+      <p:sp>
+        <p:nvSpPr>
+          <p:cNvPr id="11" name="Text 9"/>
+          <p:cNvSpPr/>
+          <p:nvPr/>
+        </p:nvSpPr>
+        <p:spPr>
+          <a:xfrm>
+            <a:off x="8778240" y="2651760"/>
+            <a:ext cx="1645920" cy="566928"/>
+          </a:xfrm>
+          <a:prstGeom prst="rect">
+            <a:avLst/>
+          </a:prstGeom>
+          <a:solidFill>
+            <a:srgbClr val="FFFFFF"/>
+          </a:solidFill>
+          <a:ln/>
+        </p:spPr>
+        <p:txBody>
+          <a:bodyPr wrap="square" rtlCol="0" anchor="ctr"/>
+          <a:lstStyle/>
+          <a:p>
+            <a:pPr algn="ctr" indent="0" marL="0">
+              <a:buNone/>
+            </a:pPr>
+            <a:r>
+              <a:rPr lang="en-US" sz="1400" dirty="0">
+                <a:solidFill>
+                  <a:srgbClr val="333333"/>
+                </a:solidFill>
+                <a:latin typeface="Aptos" pitchFamily="34" charset="0"/>
+                <a:ea typeface="Aptos" pitchFamily="34" charset="-122"/>
+                <a:cs typeface="Aptos" pitchFamily="34" charset="-120"/>
+              </a:rPr>
+              <a:t>0.94</a:t>
+            </a:r>
+            <a:endParaRPr lang="en-US" sz="1400" dirty="0"/>
+          </a:p>
+        </p:txBody>
+      </p:sp>
+      <p:sp>
+        <p:nvSpPr>
+          <p:cNvPr id="12" name="Text 10"/>
+          <p:cNvSpPr/>
+          <p:nvPr/>
+        </p:nvSpPr>
+        <p:spPr>
+          <a:xfrm>
+            <a:off x="1097280" y="3218688"/>
+            <a:ext cx="3291840" cy="566928"/>
+          </a:xfrm>
+          <a:prstGeom prst="rect">
+            <a:avLst/>
+          </a:prstGeom>
+          <a:solidFill>
+            <a:srgbClr val="F4F6F4"/>
+          </a:solidFill>
+          <a:ln/>
+        </p:spPr>
+        <p:txBody>
+          <a:bodyPr wrap="square" rtlCol="0" anchor="ctr"/>
+          <a:lstStyle/>
+          <a:p>
+            <a:pPr algn="ctr" indent="0" marL="0">
+              <a:buNone/>
+            </a:pPr>
+            <a:r>
+              <a:rPr lang="en-US" sz="1400" dirty="0">
+                <a:solidFill>
+                  <a:srgbClr val="333333"/>
+                </a:solidFill>
+                <a:latin typeface="Aptos" pitchFamily="34" charset="0"/>
+                <a:ea typeface="Aptos" pitchFamily="34" charset="-122"/>
+                <a:cs typeface="Aptos" pitchFamily="34" charset="-120"/>
+              </a:rPr>
+              <a:t>Height growth</a:t>
+            </a:r>
+            <a:endParaRPr lang="en-US" sz="1400" dirty="0"/>
+          </a:p>
+        </p:txBody>
+      </p:sp>
+      <p:sp>
+        <p:nvSpPr>
+          <p:cNvPr id="13" name="Text 11"/>
+          <p:cNvSpPr/>
+          <p:nvPr/>
+        </p:nvSpPr>
+        <p:spPr>
+          <a:xfrm>
+            <a:off x="4389120" y="3218688"/>
+            <a:ext cx="2194560" cy="566928"/>
+          </a:xfrm>
+          <a:prstGeom prst="rect">
+            <a:avLst/>
+          </a:prstGeom>
+          <a:solidFill>
+            <a:srgbClr val="F4F6F4"/>
+          </a:solidFill>
+          <a:ln/>
+        </p:spPr>
+        <p:txBody>
+          <a:bodyPr wrap="square" rtlCol="0" anchor="ctr"/>
+          <a:lstStyle/>
+          <a:p>
+            <a:pPr algn="ctr" indent="0" marL="0">
+              <a:buNone/>
+            </a:pPr>
+            <a:r>
+              <a:rPr lang="en-US" sz="1400" b="1" dirty="0">
+                <a:solidFill>
+                  <a:srgbClr val="1A3D28"/>
+                </a:solidFill>
+                <a:latin typeface="Aptos" pitchFamily="34" charset="0"/>
+                <a:ea typeface="Aptos" pitchFamily="34" charset="-122"/>
+                <a:cs typeface="Aptos" pitchFamily="34" charset="-120"/>
+              </a:rPr>
+              <a:t>0.315</a:t>
+            </a:r>
+            <a:endParaRPr lang="en-US" sz="1400" dirty="0"/>
+          </a:p>
+        </p:txBody>
+      </p:sp>
+      <p:sp>
+        <p:nvSpPr>
+          <p:cNvPr id="14" name="Text 12"/>
+          <p:cNvSpPr/>
+          <p:nvPr/>
+        </p:nvSpPr>
+        <p:spPr>
+          <a:xfrm>
+            <a:off x="6583680" y="3218688"/>
+            <a:ext cx="2194560" cy="566928"/>
+          </a:xfrm>
+          <a:prstGeom prst="rect">
+            <a:avLst/>
+          </a:prstGeom>
+          <a:solidFill>
+            <a:srgbClr val="F4F6F4"/>
+          </a:solidFill>
+          <a:ln/>
+        </p:spPr>
+        <p:txBody>
+          <a:bodyPr wrap="square" rtlCol="0" anchor="ctr"/>
+          <a:lstStyle/>
+          <a:p>
+            <a:pPr algn="ctr" indent="0" marL="0">
+              <a:buNone/>
+            </a:pPr>
+            <a:r>
+              <a:rPr lang="en-US" sz="1400" dirty="0">
+                <a:solidFill>
+                  <a:srgbClr val="333333"/>
+                </a:solidFill>
+                <a:latin typeface="Aptos" pitchFamily="34" charset="0"/>
+                <a:ea typeface="Aptos" pitchFamily="34" charset="-122"/>
+                <a:cs typeface="Aptos" pitchFamily="34" charset="-120"/>
+              </a:rPr>
+              <a:t>0.318</a:t>
+            </a:r>
+            <a:endParaRPr lang="en-US" sz="1400" dirty="0"/>
+          </a:p>
+        </p:txBody>
+      </p:sp>
+      <p:sp>
+        <p:nvSpPr>
+          <p:cNvPr id="15" name="Text 13"/>
+          <p:cNvSpPr/>
+          <p:nvPr/>
+        </p:nvSpPr>
+        <p:spPr>
+          <a:xfrm>
+            <a:off x="8778240" y="3218688"/>
+            <a:ext cx="1645920" cy="566928"/>
+          </a:xfrm>
+          <a:prstGeom prst="rect">
+            <a:avLst/>
+          </a:prstGeom>
+          <a:solidFill>
+            <a:srgbClr val="F4F6F4"/>
+          </a:solidFill>
+          <a:ln/>
+        </p:spPr>
+        <p:txBody>
+          <a:bodyPr wrap="square" rtlCol="0" anchor="ctr"/>
+          <a:lstStyle/>
+          <a:p>
+            <a:pPr algn="ctr" indent="0" marL="0">
+              <a:buNone/>
+            </a:pPr>
+            <a:r>
+              <a:rPr lang="en-US" sz="1400" dirty="0">
+                <a:solidFill>
+                  <a:srgbClr val="333333"/>
+                </a:solidFill>
+                <a:latin typeface="Aptos" pitchFamily="34" charset="0"/>
+                <a:ea typeface="Aptos" pitchFamily="34" charset="-122"/>
+                <a:cs typeface="Aptos" pitchFamily="34" charset="-120"/>
+              </a:rPr>
+              <a:t>0.93</a:t>
+            </a:r>
+            <a:endParaRPr lang="en-US" sz="1400" dirty="0"/>
+          </a:p>
+        </p:txBody>
+      </p:sp>
+      <p:sp>
+        <p:nvSpPr>
+          <p:cNvPr id="16" name="Text 14"/>
+          <p:cNvSpPr/>
+          <p:nvPr/>
+        </p:nvSpPr>
+        <p:spPr>
+          <a:xfrm>
+            <a:off x="1097280" y="3785616"/>
+            <a:ext cx="3291840" cy="566928"/>
+          </a:xfrm>
+          <a:prstGeom prst="rect">
+            <a:avLst/>
+          </a:prstGeom>
+          <a:solidFill>
+            <a:srgbClr val="FFFFFF"/>
+          </a:solidFill>
+          <a:ln/>
+        </p:spPr>
+        <p:txBody>
+          <a:bodyPr wrap="square" rtlCol="0" anchor="ctr"/>
+          <a:lstStyle/>
+          <a:p>
+            <a:pPr algn="ctr" indent="0" marL="0">
+              <a:buNone/>
+            </a:pPr>
+            <a:r>
+              <a:rPr lang="en-US" sz="1400" dirty="0">
+                <a:solidFill>
+                  <a:srgbClr val="333333"/>
+                </a:solidFill>
+                <a:latin typeface="Aptos" pitchFamily="34" charset="0"/>
+                <a:ea typeface="Aptos" pitchFamily="34" charset="-122"/>
+                <a:cs typeface="Aptos" pitchFamily="34" charset="-120"/>
+              </a:rPr>
+              <a:t>Height-diameter (cm)</a:t>
+            </a:r>
+            <a:endParaRPr lang="en-US" sz="1400" dirty="0"/>
+          </a:p>
+        </p:txBody>
+      </p:sp>
+      <p:sp>
+        <p:nvSpPr>
+          <p:cNvPr id="17" name="Text 15"/>
+          <p:cNvSpPr/>
+          <p:nvPr/>
+        </p:nvSpPr>
+        <p:spPr>
+          <a:xfrm>
+            <a:off x="4389120" y="3785616"/>
+            <a:ext cx="2194560" cy="566928"/>
+          </a:xfrm>
+          <a:prstGeom prst="rect">
+            <a:avLst/>
+          </a:prstGeom>
+          <a:solidFill>
+            <a:srgbClr val="FFFFFF"/>
+          </a:solidFill>
+          <a:ln/>
+        </p:spPr>
+        <p:txBody>
+          <a:bodyPr wrap="square" rtlCol="0" anchor="ctr"/>
+          <a:lstStyle/>
+          <a:p>
+            <a:pPr algn="ctr" indent="0" marL="0">
+              <a:buNone/>
+            </a:pPr>
+            <a:r>
+              <a:rPr lang="en-US" sz="1400" b="1" dirty="0">
+                <a:solidFill>
+                  <a:srgbClr val="1A3D28"/>
+                </a:solidFill>
+                <a:latin typeface="Aptos" pitchFamily="34" charset="0"/>
+                <a:ea typeface="Aptos" pitchFamily="34" charset="-122"/>
+                <a:cs typeface="Aptos" pitchFamily="34" charset="-120"/>
+              </a:rPr>
+              <a:t>3.55</a:t>
+            </a:r>
+            <a:endParaRPr lang="en-US" sz="1400" dirty="0"/>
+          </a:p>
+        </p:txBody>
+      </p:sp>
+      <p:sp>
+        <p:nvSpPr>
+          <p:cNvPr id="18" name="Text 16"/>
+          <p:cNvSpPr/>
+          <p:nvPr/>
+        </p:nvSpPr>
+        <p:spPr>
+          <a:xfrm>
+            <a:off x="6583680" y="3785616"/>
+            <a:ext cx="2194560" cy="566928"/>
+          </a:xfrm>
+          <a:prstGeom prst="rect">
+            <a:avLst/>
+          </a:prstGeom>
+          <a:solidFill>
+            <a:srgbClr val="FFFFFF"/>
+          </a:solidFill>
+          <a:ln/>
+        </p:spPr>
+        <p:txBody>
+          <a:bodyPr wrap="square" rtlCol="0" anchor="ctr"/>
+          <a:lstStyle/>
+          <a:p>
+            <a:pPr algn="ctr" indent="0" marL="0">
+              <a:buNone/>
+            </a:pPr>
+            <a:r>
+              <a:rPr lang="en-US" sz="1400" dirty="0">
+                <a:solidFill>
+                  <a:srgbClr val="333333"/>
+                </a:solidFill>
+                <a:latin typeface="Aptos" pitchFamily="34" charset="0"/>
+                <a:ea typeface="Aptos" pitchFamily="34" charset="-122"/>
+                <a:cs typeface="Aptos" pitchFamily="34" charset="-120"/>
+              </a:rPr>
+              <a:t>3.77</a:t>
+            </a:r>
+            <a:endParaRPr lang="en-US" sz="1400" dirty="0"/>
+          </a:p>
+        </p:txBody>
+      </p:sp>
+      <p:sp>
+        <p:nvSpPr>
+          <p:cNvPr id="19" name="Text 17"/>
+          <p:cNvSpPr/>
+          <p:nvPr/>
+        </p:nvSpPr>
+        <p:spPr>
+          <a:xfrm>
+            <a:off x="8778240" y="3785616"/>
+            <a:ext cx="1645920" cy="566928"/>
+          </a:xfrm>
+          <a:prstGeom prst="rect">
+            <a:avLst/>
+          </a:prstGeom>
+          <a:solidFill>
+            <a:srgbClr val="FFFFFF"/>
+          </a:solidFill>
+          <a:ln/>
+        </p:spPr>
+        <p:txBody>
+          <a:bodyPr wrap="square" rtlCol="0" anchor="ctr"/>
+          <a:lstStyle/>
+          <a:p>
+            <a:pPr algn="ctr" indent="0" marL="0">
+              <a:buNone/>
+            </a:pPr>
+            <a:r>
+              <a:rPr lang="en-US" sz="1400" dirty="0">
+                <a:solidFill>
+                  <a:srgbClr val="333333"/>
+                </a:solidFill>
+                <a:latin typeface="Aptos" pitchFamily="34" charset="0"/>
+                <a:ea typeface="Aptos" pitchFamily="34" charset="-122"/>
+                <a:cs typeface="Aptos" pitchFamily="34" charset="-120"/>
+              </a:rPr>
+              <a:t>0.95</a:t>
+            </a:r>
+            <a:endParaRPr lang="en-US" sz="1400" dirty="0"/>
+          </a:p>
+        </p:txBody>
+      </p:sp>
+      <p:sp>
+        <p:nvSpPr>
+          <p:cNvPr id="20" name="Text 18"/>
+          <p:cNvSpPr/>
+          <p:nvPr/>
+        </p:nvSpPr>
+        <p:spPr>
+          <a:xfrm>
+            <a:off x="731520" y="4754880"/>
+            <a:ext cx="10698480" cy="822960"/>
+          </a:xfrm>
+          <a:prstGeom prst="rect">
+            <a:avLst/>
+          </a:prstGeom>
+          <a:noFill/>
+          <a:ln/>
+        </p:spPr>
+        <p:txBody>
+          <a:bodyPr wrap="square" rtlCol="0" anchor="ctr"/>
+          <a:lstStyle/>
+          <a:p>
+            <a:pPr algn="ctr" indent="0" marL="0">
+              <a:buNone/>
+            </a:pPr>
+            <a:r>
+              <a:rPr lang="en-US" sz="1450" i="1" dirty="0">
+                <a:solidFill>
+                  <a:srgbClr val="1A3D28"/>
+                </a:solidFill>
+                <a:latin typeface="Aptos" pitchFamily="34" charset="0"/>
+                <a:ea typeface="Aptos" pitchFamily="34" charset="-122"/>
+                <a:cs typeface="Aptos" pitchFamily="34" charset="-120"/>
+              </a:rPr>
+              <a:t>Lower RMSE is better; coverage near 0.95 means the intervals are honest. The trait form wins on every component and equals the hybrid, so no per-species term is even required here.</a:t>
+            </a:r>
+            <a:endParaRPr lang="en-US" sz="1450" dirty="0"/>
+          </a:p>
+        </p:txBody>
+      </p:sp>
+      <p:sp>
+        <p:nvSpPr>
+          <p:cNvPr id="21" name="Text 19"/>
+          <p:cNvSpPr/>
+          <p:nvPr/>
+        </p:nvSpPr>
+        <p:spPr>
+          <a:xfrm>
+            <a:off x="548640" y="5897880"/>
+            <a:ext cx="9144000" cy="274320"/>
+          </a:xfrm>
+          <a:prstGeom prst="rect">
+            <a:avLst/>
+          </a:prstGeom>
+          <a:noFill/>
+          <a:ln/>
+        </p:spPr>
+        <p:txBody>
+          <a:bodyPr wrap="square" rtlCol="0" anchor="ctr"/>
+          <a:lstStyle/>
+          <a:p>
+            <a:pPr indent="0" marL="0">
+              <a:buNone/>
+            </a:pPr>
+            <a:r>
+              <a:rPr lang="en-US" sz="1000" dirty="0">
+                <a:solidFill>
+                  <a:srgbClr val="999999"/>
+                </a:solidFill>
+                <a:latin typeface="Aptos" pitchFamily="34" charset="0"/>
+                <a:ea typeface="Aptos" pitchFamily="34" charset="-122"/>
+                <a:cs typeface="Aptos" pitchFamily="34" charset="-120"/>
+              </a:rPr>
+              <a:t>A. Weiskittel, Center for Research on Sustainable Forests, University of Maine</a:t>
+            </a:r>
+            <a:endParaRPr lang="en-US" sz="1000" dirty="0"/>
+          </a:p>
+        </p:txBody>
+      </p:sp>
+      <p:sp>
+        <p:nvSpPr>
+          <p:cNvPr id="22" name="Shape 20"/>
+          <p:cNvSpPr/>
+          <p:nvPr/>
+        </p:nvSpPr>
+        <p:spPr>
+          <a:xfrm>
+            <a:off x="0" y="6263640"/>
+            <a:ext cx="12188952" cy="594360"/>
+          </a:xfrm>
+          <a:prstGeom prst="rect">
+            <a:avLst/>
+          </a:prstGeom>
+          <a:solidFill>
+            <a:srgbClr val="1A3D28"/>
+          </a:solidFill>
+          <a:ln/>
+        </p:spPr>
+      </p:sp>
+      <p:sp>
+        <p:nvSpPr>
+          <p:cNvPr id="23" name="Text 21"/>
+          <p:cNvSpPr/>
+          <p:nvPr/>
+        </p:nvSpPr>
+        <p:spPr>
+          <a:xfrm>
+            <a:off x="457200" y="6263640"/>
+            <a:ext cx="11247120" cy="594360"/>
+          </a:xfrm>
+          <a:prstGeom prst="rect">
+            <a:avLst/>
+          </a:prstGeom>
+          <a:noFill/>
+          <a:ln/>
+        </p:spPr>
+        <p:txBody>
+          <a:bodyPr wrap="square" rtlCol="0" anchor="ctr"/>
+          <a:lstStyle/>
+          <a:p>
+            <a:pPr indent="0" marL="0">
+              <a:buNone/>
+            </a:pPr>
+            <a:r>
+              <a:rPr lang="en-US" sz="1600" dirty="0">
+                <a:solidFill>
+                  <a:srgbClr val="FFFFFF"/>
+                </a:solidFill>
+                <a:latin typeface="Aptos" pitchFamily="34" charset="0"/>
+                <a:ea typeface="Aptos" pitchFamily="34" charset="-122"/>
+                <a:cs typeface="Aptos" pitchFamily="34" charset="-120"/>
+              </a:rPr>
+              <a:t>Trait-driven equations generalize as well or better than per-species fits, with calibrated uncertainty</a:t>
             </a:r>
             <a:endParaRPr lang="en-US" sz="1600" dirty="0"/>
           </a:p>

</xml_diff>